<commit_message>
fixed minor typos in the protocol figure
</commit_message>
<xml_diff>
--- a/2026 WTSC camera_ready/figures/protocol.pptx
+++ b/2026 WTSC camera_ready/figures/protocol.pptx
@@ -259,7 +259,7 @@
           <a:p>
             <a:fld id="{32E81E37-94EE-7241-9339-AD18A17806B9}" type="datetimeFigureOut">
               <a:rPr lang="en-US" smtClean="0"/>
-              <a:t>1/30/26</a:t>
+              <a:t>3/11/26</a:t>
             </a:fld>
             <a:endParaRPr lang="en-US"/>
           </a:p>
@@ -457,7 +457,7 @@
           <a:p>
             <a:fld id="{32E81E37-94EE-7241-9339-AD18A17806B9}" type="datetimeFigureOut">
               <a:rPr lang="en-US" smtClean="0"/>
-              <a:t>1/30/26</a:t>
+              <a:t>3/11/26</a:t>
             </a:fld>
             <a:endParaRPr lang="en-US"/>
           </a:p>
@@ -665,7 +665,7 @@
           <a:p>
             <a:fld id="{32E81E37-94EE-7241-9339-AD18A17806B9}" type="datetimeFigureOut">
               <a:rPr lang="en-US" smtClean="0"/>
-              <a:t>1/30/26</a:t>
+              <a:t>3/11/26</a:t>
             </a:fld>
             <a:endParaRPr lang="en-US"/>
           </a:p>
@@ -863,7 +863,7 @@
           <a:p>
             <a:fld id="{32E81E37-94EE-7241-9339-AD18A17806B9}" type="datetimeFigureOut">
               <a:rPr lang="en-US" smtClean="0"/>
-              <a:t>1/30/26</a:t>
+              <a:t>3/11/26</a:t>
             </a:fld>
             <a:endParaRPr lang="en-US"/>
           </a:p>
@@ -1138,7 +1138,7 @@
           <a:p>
             <a:fld id="{32E81E37-94EE-7241-9339-AD18A17806B9}" type="datetimeFigureOut">
               <a:rPr lang="en-US" smtClean="0"/>
-              <a:t>1/30/26</a:t>
+              <a:t>3/11/26</a:t>
             </a:fld>
             <a:endParaRPr lang="en-US"/>
           </a:p>
@@ -1403,7 +1403,7 @@
           <a:p>
             <a:fld id="{32E81E37-94EE-7241-9339-AD18A17806B9}" type="datetimeFigureOut">
               <a:rPr lang="en-US" smtClean="0"/>
-              <a:t>1/30/26</a:t>
+              <a:t>3/11/26</a:t>
             </a:fld>
             <a:endParaRPr lang="en-US"/>
           </a:p>
@@ -1815,7 +1815,7 @@
           <a:p>
             <a:fld id="{32E81E37-94EE-7241-9339-AD18A17806B9}" type="datetimeFigureOut">
               <a:rPr lang="en-US" smtClean="0"/>
-              <a:t>1/30/26</a:t>
+              <a:t>3/11/26</a:t>
             </a:fld>
             <a:endParaRPr lang="en-US"/>
           </a:p>
@@ -1956,7 +1956,7 @@
           <a:p>
             <a:fld id="{32E81E37-94EE-7241-9339-AD18A17806B9}" type="datetimeFigureOut">
               <a:rPr lang="en-US" smtClean="0"/>
-              <a:t>1/30/26</a:t>
+              <a:t>3/11/26</a:t>
             </a:fld>
             <a:endParaRPr lang="en-US"/>
           </a:p>
@@ -2069,7 +2069,7 @@
           <a:p>
             <a:fld id="{32E81E37-94EE-7241-9339-AD18A17806B9}" type="datetimeFigureOut">
               <a:rPr lang="en-US" smtClean="0"/>
-              <a:t>1/30/26</a:t>
+              <a:t>3/11/26</a:t>
             </a:fld>
             <a:endParaRPr lang="en-US"/>
           </a:p>
@@ -2380,7 +2380,7 @@
           <a:p>
             <a:fld id="{32E81E37-94EE-7241-9339-AD18A17806B9}" type="datetimeFigureOut">
               <a:rPr lang="en-US" smtClean="0"/>
-              <a:t>1/30/26</a:t>
+              <a:t>3/11/26</a:t>
             </a:fld>
             <a:endParaRPr lang="en-US"/>
           </a:p>
@@ -2668,7 +2668,7 @@
           <a:p>
             <a:fld id="{32E81E37-94EE-7241-9339-AD18A17806B9}" type="datetimeFigureOut">
               <a:rPr lang="en-US" smtClean="0"/>
-              <a:t>1/30/26</a:t>
+              <a:t>3/11/26</a:t>
             </a:fld>
             <a:endParaRPr lang="en-US"/>
           </a:p>
@@ -2909,7 +2909,7 @@
           <a:p>
             <a:fld id="{32E81E37-94EE-7241-9339-AD18A17806B9}" type="datetimeFigureOut">
               <a:rPr lang="en-US" smtClean="0"/>
-              <a:t>1/30/26</a:t>
+              <a:t>3/11/26</a:t>
             </a:fld>
             <a:endParaRPr lang="en-US"/>
           </a:p>
@@ -6184,21 +6184,35 @@
                 <a:latin typeface="NewComputerModern08" pitchFamily="2" charset="77"/>
                 <a:cs typeface="Times New Roman" panose="02020603050405020304" pitchFamily="18" charset="0"/>
               </a:rPr>
-              <a:t> call </a:t>
-            </a:r>
-            <a:r>
-              <a:rPr lang="en-US" sz="600" dirty="0" err="1">
+              <a:t> </a:t>
+            </a:r>
+            <a:r>
+              <a:rPr lang="en-US" sz="600">
                 <a:latin typeface="NewComputerModern08" pitchFamily="2" charset="77"/>
                 <a:cs typeface="Times New Roman" panose="02020603050405020304" pitchFamily="18" charset="0"/>
               </a:rPr>
-              <a:t>cata</a:t>
+              <a:t>call </a:t>
             </a:r>
             <a:r>
               <a:rPr lang="en-US" sz="600" dirty="0">
                 <a:latin typeface="NewComputerModern08" pitchFamily="2" charset="77"/>
                 <a:cs typeface="Times New Roman" panose="02020603050405020304" pitchFamily="18" charset="0"/>
               </a:rPr>
-              <a:t> to </a:t>
+              <a:t>d</a:t>
+            </a:r>
+            <a:r>
+              <a:rPr lang="en-US" sz="600">
+                <a:latin typeface="NewComputerModern08" pitchFamily="2" charset="77"/>
+                <a:cs typeface="Times New Roman" panose="02020603050405020304" pitchFamily="18" charset="0"/>
+              </a:rPr>
+              <a:t>ata </a:t>
+            </a:r>
+            <a:r>
+              <a:rPr lang="en-US" sz="600" dirty="0">
+                <a:latin typeface="NewComputerModern08" pitchFamily="2" charset="77"/>
+                <a:cs typeface="Times New Roman" panose="02020603050405020304" pitchFamily="18" charset="0"/>
+              </a:rPr>
+              <a:t>to </a:t>
             </a:r>
             <a:r>
               <a:rPr lang="en-US" sz="600" dirty="0" err="1">
@@ -6990,7 +7004,7 @@
                 <a:latin typeface="NewComputerModern08" pitchFamily="2" charset="77"/>
                 <a:cs typeface="Times New Roman" panose="02020603050405020304" pitchFamily="18" charset="0"/>
               </a:rPr>
-              <a:t>2. EA performs KZG opening of Ballot id in permutated tables</a:t>
+              <a:t>2. EA performs KZG opening of Ballot id in permuted tables</a:t>
             </a:r>
           </a:p>
           <a:p>

</xml_diff>